<commit_message>
Tighten choice XML fallback generation
  - Route XML unknown children through targeted direct and parent choice rules
  - Remove broad XmlText fallback generation for repeated choices
  - Expand round-trip coverage and diagnostics for doc samples and test data
  - Regenerate schema output and fixtures for the narrowed XML fallback model
</commit_message>
<xml_diff>
--- a/test-data/drawingml/effects.pptx
+++ b/test-data/drawingml/effects.pptx
@@ -122,16 +122,16 @@
             </a:solidFill>
           </a:ln>
           <a:effectLst>
+            <a:glow rad="127000">
+              <a:srgbClr val="4472C4">
+                <a:alpha val="50000"/>
+              </a:srgbClr>
+            </a:glow>
             <a:outerShdw blurRad="57150" dist="38100" dir="5400000" algn="ctr" rotWithShape="0">
               <a:srgbClr val="000000">
                 <a:alpha val="50000"/>
               </a:srgbClr>
             </a:outerShdw>
-            <a:glow rad="127000">
-              <a:srgbClr val="4472C4">
-                <a:alpha val="50000"/>
-              </a:srgbClr>
-            </a:glow>
           </a:effectLst>
         </p:spPr>
         <p:txBody>

</xml_diff>